<commit_message>
Revisar memoria y materiales de defensa para la entrega al tribunal
</commit_message>
<xml_diff>
--- a/Presentacion_defensa_TFG.pptx
+++ b/Presentacion_defensa_TFG.pptx
@@ -120,6 +120,11 @@
       </a:defRPr>
     </a:lvl9pPr>
   </p:defaultTextStyle>
+  <p:extLst>
+    <p:ext uri="{EFAFB233-063F-42B5-8137-9DF3F51BA10A}">
+      <p15:sldGuideLst xmlns:p15="http://schemas.microsoft.com/office/powerpoint/2012/main"/>
+    </p:ext>
+  </p:extLst>
 </p:presentation>
 </file>
 
@@ -205,7 +210,7 @@
           <a:p>
             <a:fld id="{C18776E7-F19A-4FA0-9856-598CCCB861C5}" type="datetimeFigureOut">
               <a:rPr lang="es-ES" smtClean="0"/>
-              <a:t>01/09/2026</a:t>
+              <a:t>28/09/2026</a:t>
             </a:fld>
             <a:endParaRPr lang="es-ES"/>
           </a:p>
@@ -791,7 +796,7 @@
               <a:rPr lang="es-ES"/>
               <a:t>La demostración debe durar unos tres minutos. Si falla OAuth, usar los EML sintéticos y las capturas de respaldo. En el acceso móvil solo se expone Streamlit a la LAN privada.
 [Sources]
-- docs/DEFENSE_SCREENSHOTS.md.
+- docs/images/ y defense_demo/README.md.
 - defense_demo/README.md.
 - README.md: acceso temporal desde la red local.
 [/Sources]</a:t>
@@ -1612,6 +1617,15 @@
 [/Sources]</a:t>
             </a:r>
           </a:p>
+          <a:p>
+            <a:endParaRPr lang="es-ES"/>
+          </a:p>
+          <a:p>
+            <a:r>
+              <a:rPr lang="es-ES"/>
+              <a:t>TensorFlow estaba previsto, pero el prototipo reúne TF-IDF y MLP en scikit-learn. No se entrenó ni midió una alternativa equivalente en TensorFlow: la decisión responde al alcance y a la integración, no demuestra mayor precisión o eficiencia. Fuente: memoria/alcance.tex, apartado 5.3.2.</a:t>
+            </a:r>
+          </a:p>
         </p:txBody>
       </p:sp>
       <p:sp>
@@ -1703,6 +1717,15 @@
 - EVALUATION_REPORT.md.
 - EXTERNAL_EVALUATION_REPORT.md.
 [/Sources]</a:t>
+            </a:r>
+          </a:p>
+          <a:p>
+            <a:endParaRPr lang="es-ES"/>
+          </a:p>
+          <a:p>
+            <a:r>
+              <a:rPr lang="es-ES"/>
+              <a:t>Los corpus ES son spam/ham y usan la clase positiva como proxy textual; el agregado EN mezcla spam y phishing. No equivalen íntegramente a phishing confirmado. Las cinco particiones de calibración no validan por sí mismas los pesos en datos nuevos.</a:t>
             </a:r>
           </a:p>
         </p:txBody>
@@ -1890,7 +1913,7 @@
           <a:p>
             <a:fld id="{AC7747AD-8D8A-43A2-A24D-7C12FAAD78F6}" type="datetimeFigureOut">
               <a:rPr lang="es-ES" smtClean="0"/>
-              <a:t>01/09/2026</a:t>
+              <a:t>28/09/2026</a:t>
             </a:fld>
             <a:endParaRPr lang="es-ES"/>
           </a:p>
@@ -2088,7 +2111,7 @@
           <a:p>
             <a:fld id="{AC7747AD-8D8A-43A2-A24D-7C12FAAD78F6}" type="datetimeFigureOut">
               <a:rPr lang="es-ES" smtClean="0"/>
-              <a:t>01/09/2026</a:t>
+              <a:t>28/09/2026</a:t>
             </a:fld>
             <a:endParaRPr lang="es-ES"/>
           </a:p>
@@ -2296,7 +2319,7 @@
           <a:p>
             <a:fld id="{AC7747AD-8D8A-43A2-A24D-7C12FAAD78F6}" type="datetimeFigureOut">
               <a:rPr lang="es-ES" smtClean="0"/>
-              <a:t>01/09/2026</a:t>
+              <a:t>28/09/2026</a:t>
             </a:fld>
             <a:endParaRPr lang="es-ES"/>
           </a:p>
@@ -2494,7 +2517,7 @@
           <a:p>
             <a:fld id="{AC7747AD-8D8A-43A2-A24D-7C12FAAD78F6}" type="datetimeFigureOut">
               <a:rPr lang="es-ES" smtClean="0"/>
-              <a:t>01/09/2026</a:t>
+              <a:t>28/09/2026</a:t>
             </a:fld>
             <a:endParaRPr lang="es-ES"/>
           </a:p>
@@ -2769,7 +2792,7 @@
           <a:p>
             <a:fld id="{AC7747AD-8D8A-43A2-A24D-7C12FAAD78F6}" type="datetimeFigureOut">
               <a:rPr lang="es-ES" smtClean="0"/>
-              <a:t>01/09/2026</a:t>
+              <a:t>28/09/2026</a:t>
             </a:fld>
             <a:endParaRPr lang="es-ES"/>
           </a:p>
@@ -3034,7 +3057,7 @@
           <a:p>
             <a:fld id="{AC7747AD-8D8A-43A2-A24D-7C12FAAD78F6}" type="datetimeFigureOut">
               <a:rPr lang="es-ES" smtClean="0"/>
-              <a:t>01/09/2026</a:t>
+              <a:t>28/09/2026</a:t>
             </a:fld>
             <a:endParaRPr lang="es-ES"/>
           </a:p>
@@ -3446,7 +3469,7 @@
           <a:p>
             <a:fld id="{AC7747AD-8D8A-43A2-A24D-7C12FAAD78F6}" type="datetimeFigureOut">
               <a:rPr lang="es-ES" smtClean="0"/>
-              <a:t>01/09/2026</a:t>
+              <a:t>28/09/2026</a:t>
             </a:fld>
             <a:endParaRPr lang="es-ES"/>
           </a:p>
@@ -3587,7 +3610,7 @@
           <a:p>
             <a:fld id="{AC7747AD-8D8A-43A2-A24D-7C12FAAD78F6}" type="datetimeFigureOut">
               <a:rPr lang="es-ES" smtClean="0"/>
-              <a:t>01/09/2026</a:t>
+              <a:t>28/09/2026</a:t>
             </a:fld>
             <a:endParaRPr lang="es-ES"/>
           </a:p>
@@ -3700,7 +3723,7 @@
           <a:p>
             <a:fld id="{AC7747AD-8D8A-43A2-A24D-7C12FAAD78F6}" type="datetimeFigureOut">
               <a:rPr lang="es-ES" smtClean="0"/>
-              <a:t>01/09/2026</a:t>
+              <a:t>28/09/2026</a:t>
             </a:fld>
             <a:endParaRPr lang="es-ES"/>
           </a:p>
@@ -4011,7 +4034,7 @@
           <a:p>
             <a:fld id="{AC7747AD-8D8A-43A2-A24D-7C12FAAD78F6}" type="datetimeFigureOut">
               <a:rPr lang="es-ES" smtClean="0"/>
-              <a:t>01/09/2026</a:t>
+              <a:t>28/09/2026</a:t>
             </a:fld>
             <a:endParaRPr lang="es-ES"/>
           </a:p>
@@ -4299,7 +4322,7 @@
           <a:p>
             <a:fld id="{AC7747AD-8D8A-43A2-A24D-7C12FAAD78F6}" type="datetimeFigureOut">
               <a:rPr lang="es-ES" smtClean="0"/>
-              <a:t>01/09/2026</a:t>
+              <a:t>28/09/2026</a:t>
             </a:fld>
             <a:endParaRPr lang="es-ES"/>
           </a:p>
@@ -4540,7 +4563,7 @@
           <a:p>
             <a:fld id="{AC7747AD-8D8A-43A2-A24D-7C12FAAD78F6}" type="datetimeFigureOut">
               <a:rPr lang="es-ES" smtClean="0"/>
-              <a:t>01/09/2026</a:t>
+              <a:t>28/09/2026</a:t>
             </a:fld>
             <a:endParaRPr lang="es-ES"/>
           </a:p>
@@ -12100,7 +12123,7 @@
                 </a:solidFill>
                 <a:latin typeface="Arial" panose="020B0604020202020204" pitchFamily="34" charset="0"/>
               </a:rPr>
-              <a:t>Un backend central cumple cuatro objetivos</a:t>
+              <a:t>Objetivos del prototipo desarrollado</a:t>
             </a:r>
           </a:p>
         </p:txBody>
@@ -12295,7 +12318,7 @@
         </p:nvSpPr>
         <p:spPr>
           <a:xfrm>
-            <a:off x="711200" y="2298700"/>
+            <a:off x="711200" y="2540000"/>
             <a:ext cx="6350000" cy="276999"/>
           </a:xfrm>
           <a:prstGeom prst="rect">
@@ -13112,7 +13135,7 @@
                 </a:solidFill>
                 <a:latin typeface="Arial" panose="020B0604020202020204" pitchFamily="34" charset="0"/>
               </a:rPr>
-              <a:t>Sí: es una arquitectura cliente-servidor</a:t>
+              <a:t>Arquitectura cliente-servidor</a:t>
             </a:r>
           </a:p>
         </p:txBody>
@@ -15860,7 +15883,7 @@
                 </a:solidFill>
                 <a:latin typeface="Arial" panose="020B0604020202020204" pitchFamily="34" charset="0"/>
               </a:rPr>
-              <a:t>Dos detectores aportan señales complementarias</a:t>
+              <a:t>Reglas y clasificador neuronal</a:t>
             </a:r>
           </a:p>
         </p:txBody>
@@ -16460,7 +16483,7 @@
               </a:spcAft>
             </a:pPr>
             <a:r>
-              <a:rPr lang="es-ES" b="1" sz="1800">
+              <a:rPr lang="es-ES" sz="1800" b="1">
                 <a:solidFill>
                   <a:srgbClr val="FFFFFF"/>
                 </a:solidFill>

</xml_diff>